<commit_message>
Updated model guide, created new md and pdf. Updated slides
</commit_message>
<xml_diff>
--- a/ModelGuide/ModelGuideSlides.pptx
+++ b/ModelGuide/ModelGuideSlides.pptx
@@ -7,7 +7,6 @@
   <p:sldIdLst>
     <p:sldId id="325" r:id="rId2"/>
     <p:sldId id="326" r:id="rId3"/>
-    <p:sldId id="327" r:id="rId4"/>
   </p:sldIdLst>
   <p:sldSz cx="12192000" cy="6858000"/>
   <p:notesSz cx="6858000" cy="9144000"/>
@@ -261,7 +260,7 @@
           <a:p>
             <a:fld id="{1741EC50-43F3-4A5E-9366-58CA2B63D9FB}" type="datetimeFigureOut">
               <a:rPr lang="en-US" smtClean="0"/>
-              <a:t>7/11/2025</a:t>
+              <a:t>3/12/26</a:t>
             </a:fld>
             <a:endParaRPr lang="en-US"/>
           </a:p>
@@ -459,7 +458,7 @@
           <a:p>
             <a:fld id="{1741EC50-43F3-4A5E-9366-58CA2B63D9FB}" type="datetimeFigureOut">
               <a:rPr lang="en-US" smtClean="0"/>
-              <a:t>7/11/2025</a:t>
+              <a:t>3/12/26</a:t>
             </a:fld>
             <a:endParaRPr lang="en-US"/>
           </a:p>
@@ -667,7 +666,7 @@
           <a:p>
             <a:fld id="{1741EC50-43F3-4A5E-9366-58CA2B63D9FB}" type="datetimeFigureOut">
               <a:rPr lang="en-US" smtClean="0"/>
-              <a:t>7/11/2025</a:t>
+              <a:t>3/12/26</a:t>
             </a:fld>
             <a:endParaRPr lang="en-US"/>
           </a:p>
@@ -865,7 +864,7 @@
           <a:p>
             <a:fld id="{1741EC50-43F3-4A5E-9366-58CA2B63D9FB}" type="datetimeFigureOut">
               <a:rPr lang="en-US" smtClean="0"/>
-              <a:t>7/11/2025</a:t>
+              <a:t>3/12/26</a:t>
             </a:fld>
             <a:endParaRPr lang="en-US"/>
           </a:p>
@@ -1140,7 +1139,7 @@
           <a:p>
             <a:fld id="{1741EC50-43F3-4A5E-9366-58CA2B63D9FB}" type="datetimeFigureOut">
               <a:rPr lang="en-US" smtClean="0"/>
-              <a:t>7/11/2025</a:t>
+              <a:t>3/12/26</a:t>
             </a:fld>
             <a:endParaRPr lang="en-US"/>
           </a:p>
@@ -1405,7 +1404,7 @@
           <a:p>
             <a:fld id="{1741EC50-43F3-4A5E-9366-58CA2B63D9FB}" type="datetimeFigureOut">
               <a:rPr lang="en-US" smtClean="0"/>
-              <a:t>7/11/2025</a:t>
+              <a:t>3/12/26</a:t>
             </a:fld>
             <a:endParaRPr lang="en-US"/>
           </a:p>
@@ -1817,7 +1816,7 @@
           <a:p>
             <a:fld id="{1741EC50-43F3-4A5E-9366-58CA2B63D9FB}" type="datetimeFigureOut">
               <a:rPr lang="en-US" smtClean="0"/>
-              <a:t>7/11/2025</a:t>
+              <a:t>3/12/26</a:t>
             </a:fld>
             <a:endParaRPr lang="en-US"/>
           </a:p>
@@ -1958,7 +1957,7 @@
           <a:p>
             <a:fld id="{1741EC50-43F3-4A5E-9366-58CA2B63D9FB}" type="datetimeFigureOut">
               <a:rPr lang="en-US" smtClean="0"/>
-              <a:t>7/11/2025</a:t>
+              <a:t>3/12/26</a:t>
             </a:fld>
             <a:endParaRPr lang="en-US"/>
           </a:p>
@@ -2071,7 +2070,7 @@
           <a:p>
             <a:fld id="{1741EC50-43F3-4A5E-9366-58CA2B63D9FB}" type="datetimeFigureOut">
               <a:rPr lang="en-US" smtClean="0"/>
-              <a:t>7/11/2025</a:t>
+              <a:t>3/12/26</a:t>
             </a:fld>
             <a:endParaRPr lang="en-US"/>
           </a:p>
@@ -2382,7 +2381,7 @@
           <a:p>
             <a:fld id="{1741EC50-43F3-4A5E-9366-58CA2B63D9FB}" type="datetimeFigureOut">
               <a:rPr lang="en-US" smtClean="0"/>
-              <a:t>7/11/2025</a:t>
+              <a:t>3/12/26</a:t>
             </a:fld>
             <a:endParaRPr lang="en-US"/>
           </a:p>
@@ -2670,7 +2669,7 @@
           <a:p>
             <a:fld id="{1741EC50-43F3-4A5E-9366-58CA2B63D9FB}" type="datetimeFigureOut">
               <a:rPr lang="en-US" smtClean="0"/>
-              <a:t>7/11/2025</a:t>
+              <a:t>3/12/26</a:t>
             </a:fld>
             <a:endParaRPr lang="en-US"/>
           </a:p>
@@ -2911,7 +2910,7 @@
           <a:p>
             <a:fld id="{1741EC50-43F3-4A5E-9366-58CA2B63D9FB}" type="datetimeFigureOut">
               <a:rPr lang="en-US" smtClean="0"/>
-              <a:t>7/11/2025</a:t>
+              <a:t>3/12/26</a:t>
             </a:fld>
             <a:endParaRPr lang="en-US"/>
           </a:p>
@@ -3593,10 +3592,10 @@
       </p:grpSpPr>
       <p:pic>
         <p:nvPicPr>
-          <p:cNvPr id="3" name="Picture 2" descr="A close-up of a table&#10;&#10;AI-generated content may be incorrect.">
-            <a:extLst>
-              <a:ext uri="{FF2B5EF4-FFF2-40B4-BE49-F238E27FC236}">
-                <a16:creationId xmlns:a16="http://schemas.microsoft.com/office/drawing/2014/main" id="{353131DF-9547-2E63-E78B-31A6B438DB28}"/>
+          <p:cNvPr id="4" name="Picture 3" descr="A close-up of a table&#10;&#10;AI-generated content may be incorrect.">
+            <a:extLst>
+              <a:ext uri="{FF2B5EF4-FFF2-40B4-BE49-F238E27FC236}">
+                <a16:creationId xmlns:a16="http://schemas.microsoft.com/office/drawing/2014/main" id="{31C90D80-D73D-CEE9-0A22-9B0AAA89B35E}"/>
               </a:ext>
             </a:extLst>
           </p:cNvPr>
@@ -3619,8 +3618,8 @@
         </p:blipFill>
         <p:spPr>
           <a:xfrm>
-            <a:off x="0" y="1355516"/>
-            <a:ext cx="12192000" cy="3698828"/>
+            <a:off x="0" y="1221499"/>
+            <a:ext cx="12220046" cy="4425157"/>
           </a:xfrm>
           <a:prstGeom prst="rect">
             <a:avLst/>
@@ -3631,703 +3630,6 @@
     <p:extLst>
       <p:ext uri="{BB962C8B-B14F-4D97-AF65-F5344CB8AC3E}">
         <p14:creationId xmlns:p14="http://schemas.microsoft.com/office/powerpoint/2010/main" val="1177683373"/>
-      </p:ext>
-    </p:extLst>
-  </p:cSld>
-  <p:clrMapOvr>
-    <a:masterClrMapping/>
-  </p:clrMapOvr>
-</p:sld>
-</file>
-
-<file path=ppt/slides/slide3.xml><?xml version="1.0" encoding="utf-8"?>
-<p:sld xmlns:a="http://schemas.openxmlformats.org/drawingml/2006/main" xmlns:r="http://schemas.openxmlformats.org/officeDocument/2006/relationships" xmlns:p="http://schemas.openxmlformats.org/presentationml/2006/main">
-  <p:cSld>
-    <p:spTree>
-      <p:nvGrpSpPr>
-        <p:cNvPr id="1" name="">
-          <a:extLst>
-            <a:ext uri="{FF2B5EF4-FFF2-40B4-BE49-F238E27FC236}">
-              <a16:creationId xmlns:a16="http://schemas.microsoft.com/office/drawing/2014/main" id="{4BD3BAFF-1CB4-03E0-141C-96D0747B368D}"/>
-            </a:ext>
-          </a:extLst>
-        </p:cNvPr>
-        <p:cNvGrpSpPr/>
-        <p:nvPr/>
-      </p:nvGrpSpPr>
-      <p:grpSpPr>
-        <a:xfrm>
-          <a:off x="0" y="0"/>
-          <a:ext cx="0" cy="0"/>
-          <a:chOff x="0" y="0"/>
-          <a:chExt cx="0" cy="0"/>
-        </a:xfrm>
-      </p:grpSpPr>
-      <p:pic>
-        <p:nvPicPr>
-          <p:cNvPr id="4" name="Picture 3">
-            <a:extLst>
-              <a:ext uri="{FF2B5EF4-FFF2-40B4-BE49-F238E27FC236}">
-                <a16:creationId xmlns:a16="http://schemas.microsoft.com/office/drawing/2014/main" id="{6C655AEB-9756-E0E8-2EC0-3E17D78D96CB}"/>
-              </a:ext>
-            </a:extLst>
-          </p:cNvPr>
-          <p:cNvPicPr>
-            <a:picLocks noChangeAspect="1"/>
-          </p:cNvPicPr>
-          <p:nvPr/>
-        </p:nvPicPr>
-        <p:blipFill>
-          <a:blip r:embed="rId2"/>
-          <a:stretch>
-            <a:fillRect/>
-          </a:stretch>
-        </p:blipFill>
-        <p:spPr>
-          <a:xfrm>
-            <a:off x="522994" y="2521214"/>
-            <a:ext cx="5748333" cy="2075572"/>
-          </a:xfrm>
-          <a:prstGeom prst="rect">
-            <a:avLst/>
-          </a:prstGeom>
-          <a:ln>
-            <a:solidFill>
-              <a:schemeClr val="tx1"/>
-            </a:solidFill>
-          </a:ln>
-        </p:spPr>
-      </p:pic>
-      <p:sp>
-        <p:nvSpPr>
-          <p:cNvPr id="5" name="TextBox 4">
-            <a:extLst>
-              <a:ext uri="{FF2B5EF4-FFF2-40B4-BE49-F238E27FC236}">
-                <a16:creationId xmlns:a16="http://schemas.microsoft.com/office/drawing/2014/main" id="{A785745D-A98E-29A4-CD42-35B63071D172}"/>
-              </a:ext>
-            </a:extLst>
-          </p:cNvPr>
-          <p:cNvSpPr txBox="1"/>
-          <p:nvPr/>
-        </p:nvSpPr>
-        <p:spPr>
-          <a:xfrm>
-            <a:off x="6721338" y="1865459"/>
-            <a:ext cx="2556854" cy="369332"/>
-          </a:xfrm>
-          <a:prstGeom prst="rect">
-            <a:avLst/>
-          </a:prstGeom>
-          <a:noFill/>
-        </p:spPr>
-        <p:txBody>
-          <a:bodyPr wrap="none" rtlCol="0">
-            <a:spAutoFit/>
-          </a:bodyPr>
-          <a:lstStyle/>
-          <a:p>
-            <a:r>
-              <a:rPr lang="en-US" b="1" dirty="0">
-                <a:solidFill>
-                  <a:srgbClr val="0000FF"/>
-                </a:solidFill>
-              </a:rPr>
-              <a:t>a. Enter volume in [</a:t>
-            </a:r>
-            <a:r>
-              <a:rPr lang="en-US" b="1" dirty="0" err="1">
-                <a:solidFill>
-                  <a:srgbClr val="0000FF"/>
-                </a:solidFill>
-              </a:rPr>
-              <a:t>maf</a:t>
-            </a:r>
-            <a:r>
-              <a:rPr lang="en-US" b="1" dirty="0">
-                <a:solidFill>
-                  <a:srgbClr val="0000FF"/>
-                </a:solidFill>
-              </a:rPr>
-              <a:t>].</a:t>
-            </a:r>
-          </a:p>
-        </p:txBody>
-      </p:sp>
-      <p:sp>
-        <p:nvSpPr>
-          <p:cNvPr id="6" name="TextBox 5">
-            <a:extLst>
-              <a:ext uri="{FF2B5EF4-FFF2-40B4-BE49-F238E27FC236}">
-                <a16:creationId xmlns:a16="http://schemas.microsoft.com/office/drawing/2014/main" id="{7D03BEB5-B431-672F-9F6F-9C980DDF1CF3}"/>
-              </a:ext>
-            </a:extLst>
-          </p:cNvPr>
-          <p:cNvSpPr txBox="1"/>
-          <p:nvPr/>
-        </p:nvSpPr>
-        <p:spPr>
-          <a:xfrm>
-            <a:off x="6897701" y="2237007"/>
-            <a:ext cx="3035831" cy="369332"/>
-          </a:xfrm>
-          <a:prstGeom prst="rect">
-            <a:avLst/>
-          </a:prstGeom>
-          <a:noFill/>
-        </p:spPr>
-        <p:txBody>
-          <a:bodyPr wrap="none" rtlCol="0">
-            <a:spAutoFit/>
-          </a:bodyPr>
-          <a:lstStyle/>
-          <a:p>
-            <a:r>
-              <a:rPr lang="en-US" b="1" dirty="0">
-                <a:solidFill>
-                  <a:srgbClr val="0000FF"/>
-                </a:solidFill>
-              </a:rPr>
-              <a:t>b. Enter price in [$/acre-foot].</a:t>
-            </a:r>
-          </a:p>
-        </p:txBody>
-      </p:sp>
-      <p:sp>
-        <p:nvSpPr>
-          <p:cNvPr id="7" name="TextBox 6">
-            <a:extLst>
-              <a:ext uri="{FF2B5EF4-FFF2-40B4-BE49-F238E27FC236}">
-                <a16:creationId xmlns:a16="http://schemas.microsoft.com/office/drawing/2014/main" id="{62D3E363-BDE4-0851-778B-537551931A84}"/>
-              </a:ext>
-            </a:extLst>
-          </p:cNvPr>
-          <p:cNvSpPr txBox="1"/>
-          <p:nvPr/>
-        </p:nvSpPr>
-        <p:spPr>
-          <a:xfrm>
-            <a:off x="7199502" y="2647089"/>
-            <a:ext cx="4469504" cy="923330"/>
-          </a:xfrm>
-          <a:prstGeom prst="rect">
-            <a:avLst/>
-          </a:prstGeom>
-          <a:noFill/>
-        </p:spPr>
-        <p:txBody>
-          <a:bodyPr wrap="square" rtlCol="0">
-            <a:spAutoFit/>
-          </a:bodyPr>
-          <a:lstStyle/>
-          <a:p>
-            <a:pPr marL="339725" indent="-339725"/>
-            <a:r>
-              <a:rPr lang="en-US" b="1" dirty="0">
-                <a:solidFill>
-                  <a:srgbClr val="FF9900"/>
-                </a:solidFill>
-              </a:rPr>
-              <a:t>c. Compensation will automatically populate.</a:t>
-            </a:r>
-          </a:p>
-          <a:p>
-            <a:pPr marL="227013"/>
-            <a:r>
-              <a:rPr lang="en-US" b="1" dirty="0">
-                <a:solidFill>
-                  <a:srgbClr val="FF9900"/>
-                </a:solidFill>
-              </a:rPr>
-              <a:t>Compensation = [Price][Volume]</a:t>
-            </a:r>
-          </a:p>
-          <a:p>
-            <a:pPr marL="227013"/>
-            <a:r>
-              <a:rPr lang="en-US" b="1" dirty="0">
-                <a:solidFill>
-                  <a:srgbClr val="FF9900"/>
-                </a:solidFill>
-              </a:rPr>
-              <a:t>	= [$ Million].</a:t>
-            </a:r>
-          </a:p>
-        </p:txBody>
-      </p:sp>
-      <p:sp>
-        <p:nvSpPr>
-          <p:cNvPr id="8" name="TextBox 7">
-            <a:extLst>
-              <a:ext uri="{FF2B5EF4-FFF2-40B4-BE49-F238E27FC236}">
-                <a16:creationId xmlns:a16="http://schemas.microsoft.com/office/drawing/2014/main" id="{EA2627FF-43E5-A43C-EB41-70782F9101F8}"/>
-              </a:ext>
-            </a:extLst>
-          </p:cNvPr>
-          <p:cNvSpPr txBox="1"/>
-          <p:nvPr/>
-        </p:nvSpPr>
-        <p:spPr>
-          <a:xfrm>
-            <a:off x="7172799" y="3651920"/>
-            <a:ext cx="3440463" cy="646331"/>
-          </a:xfrm>
-          <a:prstGeom prst="rect">
-            <a:avLst/>
-          </a:prstGeom>
-          <a:noFill/>
-        </p:spPr>
-        <p:txBody>
-          <a:bodyPr wrap="square" rtlCol="0">
-            <a:spAutoFit/>
-          </a:bodyPr>
-          <a:lstStyle/>
-          <a:p>
-            <a:pPr marL="339725" indent="-339725" algn="ctr"/>
-            <a:r>
-              <a:rPr lang="en-US" b="1" dirty="0">
-                <a:solidFill>
-                  <a:srgbClr val="FF9900"/>
-                </a:solidFill>
-              </a:rPr>
-              <a:t>d. Track value. Is zero when each buyer has a seller.</a:t>
-            </a:r>
-          </a:p>
-        </p:txBody>
-      </p:sp>
-      <p:sp>
-        <p:nvSpPr>
-          <p:cNvPr id="9" name="TextBox 8">
-            <a:extLst>
-              <a:ext uri="{FF2B5EF4-FFF2-40B4-BE49-F238E27FC236}">
-                <a16:creationId xmlns:a16="http://schemas.microsoft.com/office/drawing/2014/main" id="{DB469A0D-FB7B-E352-AF5A-73D4B25CD64C}"/>
-              </a:ext>
-            </a:extLst>
-          </p:cNvPr>
-          <p:cNvSpPr txBox="1"/>
-          <p:nvPr/>
-        </p:nvSpPr>
-        <p:spPr>
-          <a:xfrm>
-            <a:off x="7199502" y="4379752"/>
-            <a:ext cx="3838034" cy="646331"/>
-          </a:xfrm>
-          <a:prstGeom prst="rect">
-            <a:avLst/>
-          </a:prstGeom>
-          <a:noFill/>
-        </p:spPr>
-        <p:txBody>
-          <a:bodyPr wrap="square" rtlCol="0">
-            <a:spAutoFit/>
-          </a:bodyPr>
-          <a:lstStyle/>
-          <a:p>
-            <a:pPr marL="339725" indent="-339725" algn="ctr"/>
-            <a:r>
-              <a:rPr lang="en-US" b="1" dirty="0">
-                <a:solidFill>
-                  <a:srgbClr val="FF9900"/>
-                </a:solidFill>
-              </a:rPr>
-              <a:t>e. Account balance. Water available to sell, consume, or conserve.</a:t>
-            </a:r>
-          </a:p>
-        </p:txBody>
-      </p:sp>
-      <p:sp>
-        <p:nvSpPr>
-          <p:cNvPr id="10" name="TextBox 9">
-            <a:extLst>
-              <a:ext uri="{FF2B5EF4-FFF2-40B4-BE49-F238E27FC236}">
-                <a16:creationId xmlns:a16="http://schemas.microsoft.com/office/drawing/2014/main" id="{484A7085-F263-1FB5-C40E-897EA57D51FA}"/>
-              </a:ext>
-            </a:extLst>
-          </p:cNvPr>
-          <p:cNvSpPr txBox="1"/>
-          <p:nvPr/>
-        </p:nvSpPr>
-        <p:spPr>
-          <a:xfrm>
-            <a:off x="6942966" y="5217648"/>
-            <a:ext cx="4242636" cy="369332"/>
-          </a:xfrm>
-          <a:prstGeom prst="rect">
-            <a:avLst/>
-          </a:prstGeom>
-          <a:noFill/>
-        </p:spPr>
-        <p:txBody>
-          <a:bodyPr wrap="none" rtlCol="0">
-            <a:spAutoFit/>
-          </a:bodyPr>
-          <a:lstStyle/>
-          <a:p>
-            <a:r>
-              <a:rPr lang="en-US" b="1" dirty="0">
-                <a:solidFill>
-                  <a:srgbClr val="0000FF"/>
-                </a:solidFill>
-              </a:rPr>
-              <a:t>f. Enter volume to withdraw and consume.</a:t>
-            </a:r>
-          </a:p>
-        </p:txBody>
-      </p:sp>
-      <p:sp>
-        <p:nvSpPr>
-          <p:cNvPr id="11" name="TextBox 10">
-            <a:extLst>
-              <a:ext uri="{FF2B5EF4-FFF2-40B4-BE49-F238E27FC236}">
-                <a16:creationId xmlns:a16="http://schemas.microsoft.com/office/drawing/2014/main" id="{42E0638A-78CC-231B-18EF-BB25380930AE}"/>
-              </a:ext>
-            </a:extLst>
-          </p:cNvPr>
-          <p:cNvSpPr txBox="1"/>
-          <p:nvPr/>
-        </p:nvSpPr>
-        <p:spPr>
-          <a:xfrm>
-            <a:off x="6493069" y="5668481"/>
-            <a:ext cx="4601112" cy="369332"/>
-          </a:xfrm>
-          <a:prstGeom prst="rect">
-            <a:avLst/>
-          </a:prstGeom>
-          <a:noFill/>
-        </p:spPr>
-        <p:txBody>
-          <a:bodyPr wrap="square" rtlCol="0">
-            <a:spAutoFit/>
-          </a:bodyPr>
-          <a:lstStyle/>
-          <a:p>
-            <a:pPr marL="339725" indent="-339725" algn="ctr"/>
-            <a:r>
-              <a:rPr lang="en-US" b="1" dirty="0">
-                <a:solidFill>
-                  <a:srgbClr val="FF9900"/>
-                </a:solidFill>
-              </a:rPr>
-              <a:t>g. End balance = Available water ― Withdraw.</a:t>
-            </a:r>
-          </a:p>
-        </p:txBody>
-      </p:sp>
-      <p:cxnSp>
-        <p:nvCxnSpPr>
-          <p:cNvPr id="13" name="Straight Arrow Connector 12">
-            <a:extLst>
-              <a:ext uri="{FF2B5EF4-FFF2-40B4-BE49-F238E27FC236}">
-                <a16:creationId xmlns:a16="http://schemas.microsoft.com/office/drawing/2014/main" id="{51C40484-719B-9D26-0887-AF7B3F14EFC4}"/>
-              </a:ext>
-            </a:extLst>
-          </p:cNvPr>
-          <p:cNvCxnSpPr>
-            <a:cxnSpLocks/>
-          </p:cNvCxnSpPr>
-          <p:nvPr/>
-        </p:nvCxnSpPr>
-        <p:spPr>
-          <a:xfrm flipH="1">
-            <a:off x="6154824" y="2168665"/>
-            <a:ext cx="566514" cy="946769"/>
-          </a:xfrm>
-          <a:prstGeom prst="straightConnector1">
-            <a:avLst/>
-          </a:prstGeom>
-          <a:ln w="19050">
-            <a:solidFill>
-              <a:srgbClr val="0000FF"/>
-            </a:solidFill>
-            <a:tailEnd type="triangle"/>
-          </a:ln>
-        </p:spPr>
-        <p:style>
-          <a:lnRef idx="1">
-            <a:schemeClr val="accent1"/>
-          </a:lnRef>
-          <a:fillRef idx="0">
-            <a:schemeClr val="accent1"/>
-          </a:fillRef>
-          <a:effectRef idx="0">
-            <a:schemeClr val="accent1"/>
-          </a:effectRef>
-          <a:fontRef idx="minor">
-            <a:schemeClr val="tx1"/>
-          </a:fontRef>
-        </p:style>
-      </p:cxnSp>
-      <p:cxnSp>
-        <p:nvCxnSpPr>
-          <p:cNvPr id="14" name="Straight Arrow Connector 13">
-            <a:extLst>
-              <a:ext uri="{FF2B5EF4-FFF2-40B4-BE49-F238E27FC236}">
-                <a16:creationId xmlns:a16="http://schemas.microsoft.com/office/drawing/2014/main" id="{614331FF-AFC7-66AB-17BF-5A7FE9F6D5C1}"/>
-              </a:ext>
-            </a:extLst>
-          </p:cNvPr>
-          <p:cNvCxnSpPr>
-            <a:cxnSpLocks/>
-            <a:stCxn id="6" idx="1"/>
-          </p:cNvCxnSpPr>
-          <p:nvPr/>
-        </p:nvCxnSpPr>
-        <p:spPr>
-          <a:xfrm flipH="1">
-            <a:off x="6154824" y="2421673"/>
-            <a:ext cx="742877" cy="922184"/>
-          </a:xfrm>
-          <a:prstGeom prst="straightConnector1">
-            <a:avLst/>
-          </a:prstGeom>
-          <a:ln w="19050">
-            <a:solidFill>
-              <a:srgbClr val="0000FF"/>
-            </a:solidFill>
-            <a:tailEnd type="triangle"/>
-          </a:ln>
-        </p:spPr>
-        <p:style>
-          <a:lnRef idx="1">
-            <a:schemeClr val="accent1"/>
-          </a:lnRef>
-          <a:fillRef idx="0">
-            <a:schemeClr val="accent1"/>
-          </a:fillRef>
-          <a:effectRef idx="0">
-            <a:schemeClr val="accent1"/>
-          </a:effectRef>
-          <a:fontRef idx="minor">
-            <a:schemeClr val="tx1"/>
-          </a:fontRef>
-        </p:style>
-      </p:cxnSp>
-      <p:cxnSp>
-        <p:nvCxnSpPr>
-          <p:cNvPr id="20" name="Straight Arrow Connector 19">
-            <a:extLst>
-              <a:ext uri="{FF2B5EF4-FFF2-40B4-BE49-F238E27FC236}">
-                <a16:creationId xmlns:a16="http://schemas.microsoft.com/office/drawing/2014/main" id="{32B175C9-3AA8-1718-A8F9-52A04B266BC2}"/>
-              </a:ext>
-            </a:extLst>
-          </p:cNvPr>
-          <p:cNvCxnSpPr>
-            <a:cxnSpLocks/>
-            <a:endCxn id="4" idx="3"/>
-          </p:cNvCxnSpPr>
-          <p:nvPr/>
-        </p:nvCxnSpPr>
-        <p:spPr>
-          <a:xfrm flipH="1">
-            <a:off x="6271327" y="2882765"/>
-            <a:ext cx="928175" cy="676235"/>
-          </a:xfrm>
-          <a:prstGeom prst="straightConnector1">
-            <a:avLst/>
-          </a:prstGeom>
-          <a:ln w="19050">
-            <a:solidFill>
-              <a:srgbClr val="FF9900"/>
-            </a:solidFill>
-            <a:tailEnd type="triangle"/>
-          </a:ln>
-        </p:spPr>
-        <p:style>
-          <a:lnRef idx="1">
-            <a:schemeClr val="accent1"/>
-          </a:lnRef>
-          <a:fillRef idx="0">
-            <a:schemeClr val="accent1"/>
-          </a:fillRef>
-          <a:effectRef idx="0">
-            <a:schemeClr val="accent1"/>
-          </a:effectRef>
-          <a:fontRef idx="minor">
-            <a:schemeClr val="tx1"/>
-          </a:fontRef>
-        </p:style>
-      </p:cxnSp>
-      <p:cxnSp>
-        <p:nvCxnSpPr>
-          <p:cNvPr id="23" name="Straight Arrow Connector 22">
-            <a:extLst>
-              <a:ext uri="{FF2B5EF4-FFF2-40B4-BE49-F238E27FC236}">
-                <a16:creationId xmlns:a16="http://schemas.microsoft.com/office/drawing/2014/main" id="{6F049BB4-7D59-AE72-63CB-BFFAC27CA1CF}"/>
-              </a:ext>
-            </a:extLst>
-          </p:cNvPr>
-          <p:cNvCxnSpPr>
-            <a:cxnSpLocks/>
-          </p:cNvCxnSpPr>
-          <p:nvPr/>
-        </p:nvCxnSpPr>
-        <p:spPr>
-          <a:xfrm flipH="1" flipV="1">
-            <a:off x="6213075" y="3815102"/>
-            <a:ext cx="986427" cy="16955"/>
-          </a:xfrm>
-          <a:prstGeom prst="straightConnector1">
-            <a:avLst/>
-          </a:prstGeom>
-          <a:ln w="19050">
-            <a:solidFill>
-              <a:srgbClr val="FF9900"/>
-            </a:solidFill>
-            <a:tailEnd type="triangle"/>
-          </a:ln>
-        </p:spPr>
-        <p:style>
-          <a:lnRef idx="1">
-            <a:schemeClr val="accent1"/>
-          </a:lnRef>
-          <a:fillRef idx="0">
-            <a:schemeClr val="accent1"/>
-          </a:fillRef>
-          <a:effectRef idx="0">
-            <a:schemeClr val="accent1"/>
-          </a:effectRef>
-          <a:fontRef idx="minor">
-            <a:schemeClr val="tx1"/>
-          </a:fontRef>
-        </p:style>
-      </p:cxnSp>
-      <p:cxnSp>
-        <p:nvCxnSpPr>
-          <p:cNvPr id="26" name="Straight Arrow Connector 25">
-            <a:extLst>
-              <a:ext uri="{FF2B5EF4-FFF2-40B4-BE49-F238E27FC236}">
-                <a16:creationId xmlns:a16="http://schemas.microsoft.com/office/drawing/2014/main" id="{9E1090B9-B14E-F5E0-6041-ECDB30BB7AE5}"/>
-              </a:ext>
-            </a:extLst>
-          </p:cNvPr>
-          <p:cNvCxnSpPr>
-            <a:cxnSpLocks/>
-          </p:cNvCxnSpPr>
-          <p:nvPr/>
-        </p:nvCxnSpPr>
-        <p:spPr>
-          <a:xfrm flipH="1" flipV="1">
-            <a:off x="6186372" y="4033186"/>
-            <a:ext cx="1013130" cy="543877"/>
-          </a:xfrm>
-          <a:prstGeom prst="straightConnector1">
-            <a:avLst/>
-          </a:prstGeom>
-          <a:ln w="19050">
-            <a:solidFill>
-              <a:srgbClr val="FF9900"/>
-            </a:solidFill>
-            <a:tailEnd type="triangle"/>
-          </a:ln>
-        </p:spPr>
-        <p:style>
-          <a:lnRef idx="1">
-            <a:schemeClr val="accent1"/>
-          </a:lnRef>
-          <a:fillRef idx="0">
-            <a:schemeClr val="accent1"/>
-          </a:fillRef>
-          <a:effectRef idx="0">
-            <a:schemeClr val="accent1"/>
-          </a:effectRef>
-          <a:fontRef idx="minor">
-            <a:schemeClr val="tx1"/>
-          </a:fontRef>
-        </p:style>
-      </p:cxnSp>
-      <p:cxnSp>
-        <p:nvCxnSpPr>
-          <p:cNvPr id="28" name="Straight Arrow Connector 27">
-            <a:extLst>
-              <a:ext uri="{FF2B5EF4-FFF2-40B4-BE49-F238E27FC236}">
-                <a16:creationId xmlns:a16="http://schemas.microsoft.com/office/drawing/2014/main" id="{E6FC8EDB-0045-8375-1FFC-4749974C1DD5}"/>
-              </a:ext>
-            </a:extLst>
-          </p:cNvPr>
-          <p:cNvCxnSpPr>
-            <a:cxnSpLocks/>
-          </p:cNvCxnSpPr>
-          <p:nvPr/>
-        </p:nvCxnSpPr>
-        <p:spPr>
-          <a:xfrm flipH="1" flipV="1">
-            <a:off x="5963830" y="4594018"/>
-            <a:ext cx="624426" cy="1184462"/>
-          </a:xfrm>
-          <a:prstGeom prst="straightConnector1">
-            <a:avLst/>
-          </a:prstGeom>
-          <a:ln w="19050">
-            <a:solidFill>
-              <a:srgbClr val="FF9900"/>
-            </a:solidFill>
-            <a:tailEnd type="triangle"/>
-          </a:ln>
-        </p:spPr>
-        <p:style>
-          <a:lnRef idx="1">
-            <a:schemeClr val="accent1"/>
-          </a:lnRef>
-          <a:fillRef idx="0">
-            <a:schemeClr val="accent1"/>
-          </a:fillRef>
-          <a:effectRef idx="0">
-            <a:schemeClr val="accent1"/>
-          </a:effectRef>
-          <a:fontRef idx="minor">
-            <a:schemeClr val="tx1"/>
-          </a:fontRef>
-        </p:style>
-      </p:cxnSp>
-      <p:cxnSp>
-        <p:nvCxnSpPr>
-          <p:cNvPr id="30" name="Straight Arrow Connector 29">
-            <a:extLst>
-              <a:ext uri="{FF2B5EF4-FFF2-40B4-BE49-F238E27FC236}">
-                <a16:creationId xmlns:a16="http://schemas.microsoft.com/office/drawing/2014/main" id="{13944708-1DF0-9699-4DB8-1E61ED367BFA}"/>
-              </a:ext>
-            </a:extLst>
-          </p:cNvPr>
-          <p:cNvCxnSpPr>
-            <a:cxnSpLocks/>
-            <a:stCxn id="10" idx="1"/>
-          </p:cNvCxnSpPr>
-          <p:nvPr/>
-        </p:nvCxnSpPr>
-        <p:spPr>
-          <a:xfrm flipH="1" flipV="1">
-            <a:off x="6154824" y="4263745"/>
-            <a:ext cx="788142" cy="1138569"/>
-          </a:xfrm>
-          <a:prstGeom prst="straightConnector1">
-            <a:avLst/>
-          </a:prstGeom>
-          <a:ln w="19050">
-            <a:solidFill>
-              <a:srgbClr val="0000FF"/>
-            </a:solidFill>
-            <a:tailEnd type="triangle"/>
-          </a:ln>
-        </p:spPr>
-        <p:style>
-          <a:lnRef idx="1">
-            <a:schemeClr val="accent1"/>
-          </a:lnRef>
-          <a:fillRef idx="0">
-            <a:schemeClr val="accent1"/>
-          </a:fillRef>
-          <a:effectRef idx="0">
-            <a:schemeClr val="accent1"/>
-          </a:effectRef>
-          <a:fontRef idx="minor">
-            <a:schemeClr val="tx1"/>
-          </a:fontRef>
-        </p:style>
-      </p:cxnSp>
-    </p:spTree>
-    <p:extLst>
-      <p:ext uri="{BB962C8B-B14F-4D97-AF65-F5344CB8AC3E}">
-        <p14:creationId xmlns:p14="http://schemas.microsoft.com/office/powerpoint/2010/main" val="3195756581"/>
       </p:ext>
     </p:extLst>
   </p:cSld>

</xml_diff>